<commit_message>
Simplify slide 2 to three Polish example responses
</commit_message>
<xml_diff>
--- a/docs/ABB_Workflow_Support_Slides.pptx
+++ b/docs/ABB_Workflow_Support_Slides.pptx
@@ -662,7 +662,7 @@
           <a:lstStyle/>
           <a:p>
             <a:r>
-              <a:t>Źródło: dostarczony chatgpt-astra-training.html, moduł „Stochasticity: One Prompt, Several Valid Answers”, slajdy „One Prompt, Several Valid Answers” i „Reduce Unwanted Variability”. Przykłady są ilustracjami, a nie zapisami pomiaru. Jasne instrukcje redukują niejednoznaczność, ale nie gwarantują identycznych ani poprawnych wyników. Powtarzana zgodność nie zastępuje weryfikacji.</a:t>
+              <a:t>Trzy przykładowe, autorskie odpowiedzi na to samo pytanie o dwutygodniową podróż do Tajlandii. Ilustrują różnice struktury, kolejności i stopnia doprecyzowania. Nie są zapisem zmierzonych wywołań modelu ani zweryfikowanym planem podróży. Inspiracja: dostarczony chatgpt-astra-training.html, moduł „Stochasticity: One Prompt, Several Valid Answers”.</a:t>
             </a:r>
           </a:p>
         </p:txBody>
@@ -9897,59 +9897,14 @@
       </p:sp>
       <p:sp>
         <p:nvSpPr>
-          <p:cNvPr id="6" name="TextBox 5"/>
-          <p:cNvSpPr txBox="1"/>
+          <p:cNvPr id="6" name="Rectangle 5"/>
+          <p:cNvSpPr/>
           <p:nvPr/>
         </p:nvSpPr>
         <p:spPr>
           <a:xfrm>
-            <a:off x="612648" y="1901952"/>
-            <a:ext cx="13853160" cy="566928"/>
-          </a:xfrm>
-          <a:prstGeom prst="rect">
-            <a:avLst/>
-          </a:prstGeom>
-          <a:noFill/>
-        </p:spPr>
-        <p:txBody>
-          <a:bodyPr wrap="square" lIns="0" rIns="0" tIns="0" bIns="0" anchor="t">
-            <a:spAutoFit/>
-          </a:bodyPr>
-          <a:lstStyle/>
-          <a:p>
-            <a:pPr algn="l">
-              <a:lnSpc>
-                <a:spcPct val="108000"/>
-              </a:lnSpc>
-              <a:spcBef>
-                <a:spcPts val="0"/>
-              </a:spcBef>
-              <a:spcAft>
-                <a:spcPts val="0"/>
-              </a:spcAft>
-            </a:pPr>
-            <a:r>
-              <a:rPr sz="2025" b="0" lang="pl-PL">
-                <a:solidFill>
-                  <a:srgbClr val="192F3C"/>
-                </a:solidFill>
-                <a:latin typeface="DejaVu Sans"/>
-              </a:rPr>
-              <a:t>Generowanie jest probabilistyczne: mogą zmieniać się słowa, kolejność i wnioski.</a:t>
-            </a:r>
-          </a:p>
-        </p:txBody>
-      </p:sp>
-      <p:sp>
-        <p:nvSpPr>
-          <p:cNvPr id="7" name="Rectangle 6"/>
-          <p:cNvSpPr/>
-          <p:nvPr/>
-        </p:nvSpPr>
-        <p:spPr>
-          <a:xfrm>
-            <a:off x="612648" y="2697480"/>
-            <a:ext cx="14017752" cy="731520"/>
+            <a:off x="612648" y="2075688"/>
+            <a:ext cx="4489704" cy="5687568"/>
           </a:xfrm>
           <a:prstGeom prst="rect">
             <a:avLst/>
@@ -9987,14 +9942,14 @@
       </p:sp>
       <p:sp>
         <p:nvSpPr>
-          <p:cNvPr id="8" name="TextBox 7"/>
+          <p:cNvPr id="7" name="TextBox 6"/>
           <p:cNvSpPr txBox="1"/>
           <p:nvPr/>
         </p:nvSpPr>
         <p:spPr>
           <a:xfrm>
-            <a:off x="832104" y="2880360"/>
-            <a:ext cx="13569696" cy="393192"/>
+            <a:off x="841248" y="2331720"/>
+            <a:ext cx="4032504" cy="402336"/>
           </a:xfrm>
           <a:prstGeom prst="rect">
             <a:avLst/>
@@ -10002,30 +9957,107 @@
           <a:noFill/>
         </p:spPr>
         <p:txBody>
-          <a:bodyPr wrap="square" lIns="0" rIns="0" tIns="0" bIns="0" anchor="t">
+          <a:bodyPr wrap="square" lIns="0" rIns="0" tIns="0" bIns="0">
             <a:spAutoFit/>
           </a:bodyPr>
           <a:lstStyle/>
           <a:p>
-            <a:pPr algn="l">
-              <a:lnSpc>
-                <a:spcPct val="108000"/>
-              </a:lnSpc>
-              <a:spcBef>
-                <a:spcPts val="0"/>
-              </a:spcBef>
-              <a:spcAft>
-                <a:spcPts val="0"/>
+            <a:pPr>
+              <a:lnSpc>
+                <a:spcPct val="115000"/>
+              </a:lnSpc>
+              <a:spcAft>
+                <a:spcPts val="1200"/>
               </a:spcAft>
             </a:pPr>
             <a:r>
-              <a:rPr sz="2050" b="1" lang="pl-PL">
+              <a:rPr sz="2300" b="1" lang="pl-PL">
+                <a:solidFill>
+                  <a:srgbClr val="006C86"/>
+                </a:solidFill>
+                <a:latin typeface="DejaVu Sans"/>
+              </a:rPr>
+              <a:t>Odpowiedź 1</a:t>
+            </a:r>
+          </a:p>
+        </p:txBody>
+      </p:sp>
+      <p:sp>
+        <p:nvSpPr>
+          <p:cNvPr id="8" name="TextBox 7"/>
+          <p:cNvSpPr txBox="1"/>
+          <p:nvPr/>
+        </p:nvSpPr>
+        <p:spPr>
+          <a:xfrm>
+            <a:off x="841248" y="2953512"/>
+            <a:ext cx="4032504" cy="4517136"/>
+          </a:xfrm>
+          <a:prstGeom prst="rect">
+            <a:avLst/>
+          </a:prstGeom>
+          <a:noFill/>
+        </p:spPr>
+        <p:txBody>
+          <a:bodyPr wrap="square" lIns="0" rIns="0" tIns="0" bIns="0">
+            <a:spAutoFit/>
+          </a:bodyPr>
+          <a:lstStyle/>
+          <a:p>
+            <a:pPr>
+              <a:lnSpc>
+                <a:spcPct val="115000"/>
+              </a:lnSpc>
+              <a:spcAft>
+                <a:spcPts val="1200"/>
+              </a:spcAft>
+            </a:pPr>
+            <a:r>
+              <a:rPr sz="1800" b="0" lang="pl-PL">
                 <a:solidFill>
                   <a:srgbClr val="192F3C"/>
                 </a:solidFill>
                 <a:latin typeface="DejaVu Sans"/>
               </a:rPr>
-              <a:t>„Zaplanuj dwa tygodnie w Tajlandii. Co warto zobaczyć?”</a:t>
+              <a:t>Zacznij od czterech dni w Bangkoku. Zobacz Wielki Pałac, świątynię Wat Phra Kaew i Wat Arun. Wieczorem odwiedź Chinatown.</a:t>
+            </a:r>
+          </a:p>
+          <a:p>
+            <a:pPr>
+              <a:lnSpc>
+                <a:spcPct val="115000"/>
+              </a:lnSpc>
+              <a:spcAft>
+                <a:spcPts val="1200"/>
+              </a:spcAft>
+            </a:pPr>
+            <a:r>
+              <a:rPr sz="1800" b="0" lang="pl-PL">
+                <a:solidFill>
+                  <a:srgbClr val="192F3C"/>
+                </a:solidFill>
+                <a:latin typeface="DejaVu Sans"/>
+              </a:rPr>
+              <a:t>Następnie spędź cztery dni w Chiang Mai: poznaj stare miasto, odwiedź Doi Suthep i wybierz się na warsztaty kuchni tajskiej.</a:t>
+            </a:r>
+          </a:p>
+          <a:p>
+            <a:pPr>
+              <a:lnSpc>
+                <a:spcPct val="115000"/>
+              </a:lnSpc>
+              <a:spcAft>
+                <a:spcPts val="1200"/>
+              </a:spcAft>
+            </a:pPr>
+            <a:r>
+              <a:rPr sz="1800" b="0" lang="pl-PL">
+                <a:solidFill>
+                  <a:srgbClr val="192F3C"/>
+                </a:solidFill>
+                <a:latin typeface="DejaVu Sans"/>
+              </a:rPr>
+              <a:t>Ostatnie sześć dni przeznacz na Krabi i pobliskie wyspy. Połącz plażowanie z wycieczką łodzią i zostaw czas na odpoczynek.</a:t>
             </a:r>
           </a:p>
         </p:txBody>
@@ -10038,8 +10070,8 @@
         </p:nvSpPr>
         <p:spPr>
           <a:xfrm>
-            <a:off x="612648" y="3694176"/>
-            <a:ext cx="4489704" cy="1508760"/>
+            <a:off x="5376672" y="2075688"/>
+            <a:ext cx="4489704" cy="5687568"/>
           </a:xfrm>
           <a:prstGeom prst="rect">
             <a:avLst/>
@@ -10083,8 +10115,8 @@
         </p:nvSpPr>
         <p:spPr>
           <a:xfrm>
-            <a:off x="813816" y="3867912"/>
-            <a:ext cx="594360" cy="365760"/>
+            <a:off x="5605272" y="2331720"/>
+            <a:ext cx="4032504" cy="402336"/>
           </a:xfrm>
           <a:prstGeom prst="rect">
             <a:avLst/>
@@ -10092,30 +10124,27 @@
           <a:noFill/>
         </p:spPr>
         <p:txBody>
-          <a:bodyPr wrap="square" lIns="0" rIns="0" tIns="0" bIns="0" anchor="t">
+          <a:bodyPr wrap="square" lIns="0" rIns="0" tIns="0" bIns="0">
             <a:spAutoFit/>
           </a:bodyPr>
           <a:lstStyle/>
           <a:p>
-            <a:pPr algn="l">
-              <a:lnSpc>
-                <a:spcPct val="108000"/>
-              </a:lnSpc>
-              <a:spcBef>
-                <a:spcPts val="0"/>
-              </a:spcBef>
-              <a:spcAft>
-                <a:spcPts val="0"/>
+            <a:pPr>
+              <a:lnSpc>
+                <a:spcPct val="115000"/>
+              </a:lnSpc>
+              <a:spcAft>
+                <a:spcPts val="1200"/>
               </a:spcAft>
             </a:pPr>
             <a:r>
-              <a:rPr sz="2400" b="1" lang="pl-PL">
+              <a:rPr sz="2300" b="1" lang="pl-PL">
                 <a:solidFill>
                   <a:srgbClr val="006C86"/>
                 </a:solidFill>
                 <a:latin typeface="DejaVu Sans"/>
               </a:rPr>
-              <a:t>01</a:t>
+              <a:t>Odpowiedź 2</a:t>
             </a:r>
           </a:p>
         </p:txBody>
@@ -10128,8 +10157,8 @@
         </p:nvSpPr>
         <p:spPr>
           <a:xfrm>
-            <a:off x="1527048" y="3886200"/>
-            <a:ext cx="3346704" cy="365760"/>
+            <a:off x="5605272" y="2953512"/>
+            <a:ext cx="4032504" cy="4517136"/>
           </a:xfrm>
           <a:prstGeom prst="rect">
             <a:avLst/>
@@ -10137,111 +10166,79 @@
           <a:noFill/>
         </p:spPr>
         <p:txBody>
-          <a:bodyPr wrap="square" lIns="0" rIns="0" tIns="0" bIns="0" anchor="t">
+          <a:bodyPr wrap="square" lIns="0" rIns="0" tIns="0" bIns="0">
             <a:spAutoFit/>
           </a:bodyPr>
           <a:lstStyle/>
           <a:p>
-            <a:pPr algn="l">
-              <a:lnSpc>
-                <a:spcPct val="108000"/>
-              </a:lnSpc>
-              <a:spcBef>
-                <a:spcPts val="0"/>
-              </a:spcBef>
-              <a:spcAft>
-                <a:spcPts val="0"/>
+            <a:pPr>
+              <a:lnSpc>
+                <a:spcPct val="115000"/>
+              </a:lnSpc>
+              <a:spcAft>
+                <a:spcPts val="1200"/>
               </a:spcAft>
             </a:pPr>
             <a:r>
-              <a:rPr sz="1900" b="1" lang="pl-PL">
+              <a:rPr sz="1800" b="0" lang="pl-PL">
                 <a:solidFill>
                   <a:srgbClr val="192F3C"/>
                 </a:solidFill>
                 <a:latin typeface="DejaVu Sans"/>
               </a:rPr>
-              <a:t>Plan według miejsc</a:t>
-            </a:r>
-          </a:p>
-        </p:txBody>
-      </p:sp>
-      <p:sp>
-        <p:nvSpPr>
-          <p:cNvPr id="12" name="TextBox 11"/>
-          <p:cNvSpPr txBox="1"/>
+              <a:t>Połącz kulturę, przyrodę i plaże. Najpierw zdecyduj, czy wolisz intensywne zwiedzanie, czy spokojniejszy wypoczynek.</a:t>
+            </a:r>
+          </a:p>
+          <a:p>
+            <a:pPr>
+              <a:lnSpc>
+                <a:spcPct val="115000"/>
+              </a:lnSpc>
+              <a:spcAft>
+                <a:spcPts val="1200"/>
+              </a:spcAft>
+            </a:pPr>
+            <a:r>
+              <a:rPr sz="1800" b="0" lang="pl-PL">
+                <a:solidFill>
+                  <a:srgbClr val="192F3C"/>
+                </a:solidFill>
+                <a:latin typeface="DejaVu Sans"/>
+              </a:rPr>
+              <a:t>Na kulturę wybierz Bangkok i dawną stolicę Ayutthayę. Na przyrodę — Chiang Mai i górskie krajobrazy północnej Tajlandii.</a:t>
+            </a:r>
+          </a:p>
+          <a:p>
+            <a:pPr>
+              <a:lnSpc>
+                <a:spcPct val="115000"/>
+              </a:lnSpc>
+              <a:spcAft>
+                <a:spcPts val="1200"/>
+              </a:spcAft>
+            </a:pPr>
+            <a:r>
+              <a:rPr sz="1800" b="0" lang="pl-PL">
+                <a:solidFill>
+                  <a:srgbClr val="192F3C"/>
+                </a:solidFill>
+                <a:latin typeface="DejaVu Sans"/>
+              </a:rPr>
+              <a:t>Na zakończenie wybierz Krabi. Ogranicz przejazdy, by mieć więcej czasu na miejscu. Jaki masz budżet i kiedy chcesz jechać?</a:t>
+            </a:r>
+          </a:p>
+        </p:txBody>
+      </p:sp>
+      <p:sp>
+        <p:nvSpPr>
+          <p:cNvPr id="12" name="Rectangle 11"/>
+          <p:cNvSpPr/>
           <p:nvPr/>
         </p:nvSpPr>
         <p:spPr>
           <a:xfrm>
-            <a:off x="822960" y="4434840"/>
-            <a:ext cx="4041648" cy="576072"/>
-          </a:xfrm>
-          <a:prstGeom prst="rect">
-            <a:avLst/>
-          </a:prstGeom>
-          <a:noFill/>
-        </p:spPr>
-        <p:txBody>
-          <a:bodyPr wrap="square" lIns="0" rIns="0" tIns="0" bIns="0" anchor="t">
-            <a:spAutoFit/>
-          </a:bodyPr>
-          <a:lstStyle/>
-          <a:p>
-            <a:pPr algn="l">
-              <a:lnSpc>
-                <a:spcPct val="108000"/>
-              </a:lnSpc>
-              <a:spcBef>
-                <a:spcPts val="0"/>
-              </a:spcBef>
-              <a:spcAft>
-                <a:spcPts val="0"/>
-              </a:spcAft>
-            </a:pPr>
-            <a:r>
-              <a:rPr sz="1750" b="0" lang="pl-PL">
-                <a:solidFill>
-                  <a:srgbClr val="192F3C"/>
-                </a:solidFill>
-                <a:latin typeface="DejaVu Sans"/>
-              </a:rPr>
-              <a:t>Bangkok → północ Tajlandii</a:t>
-            </a:r>
-          </a:p>
-          <a:p>
-            <a:pPr algn="l">
-              <a:lnSpc>
-                <a:spcPct val="108000"/>
-              </a:lnSpc>
-              <a:spcBef>
-                <a:spcPts val="0"/>
-              </a:spcBef>
-              <a:spcAft>
-                <a:spcPts val="0"/>
-              </a:spcAft>
-            </a:pPr>
-            <a:r>
-              <a:rPr sz="1750" b="0" lang="pl-PL">
-                <a:solidFill>
-                  <a:srgbClr val="192F3C"/>
-                </a:solidFill>
-                <a:latin typeface="DejaVu Sans"/>
-              </a:rPr>
-              <a:t>→ plaże i wyspy</a:t>
-            </a:r>
-          </a:p>
-        </p:txBody>
-      </p:sp>
-      <p:sp>
-        <p:nvSpPr>
-          <p:cNvPr id="13" name="Rectangle 12"/>
-          <p:cNvSpPr/>
-          <p:nvPr/>
-        </p:nvSpPr>
-        <p:spPr>
-          <a:xfrm>
-            <a:off x="5376672" y="3694176"/>
-            <a:ext cx="4489704" cy="1508760"/>
+            <a:off x="10140696" y="2075688"/>
+            <a:ext cx="4489704" cy="5687568"/>
           </a:xfrm>
           <a:prstGeom prst="rect">
             <a:avLst/>
@@ -10279,14 +10276,14 @@
       </p:sp>
       <p:sp>
         <p:nvSpPr>
-          <p:cNvPr id="14" name="TextBox 13"/>
+          <p:cNvPr id="13" name="TextBox 12"/>
           <p:cNvSpPr txBox="1"/>
           <p:nvPr/>
         </p:nvSpPr>
         <p:spPr>
           <a:xfrm>
-            <a:off x="5577840" y="3867912"/>
-            <a:ext cx="594360" cy="365760"/>
+            <a:off x="10369296" y="2331720"/>
+            <a:ext cx="4032504" cy="402336"/>
           </a:xfrm>
           <a:prstGeom prst="rect">
             <a:avLst/>
@@ -10294,44 +10291,41 @@
           <a:noFill/>
         </p:spPr>
         <p:txBody>
-          <a:bodyPr wrap="square" lIns="0" rIns="0" tIns="0" bIns="0" anchor="t">
+          <a:bodyPr wrap="square" lIns="0" rIns="0" tIns="0" bIns="0">
             <a:spAutoFit/>
           </a:bodyPr>
           <a:lstStyle/>
           <a:p>
-            <a:pPr algn="l">
-              <a:lnSpc>
-                <a:spcPct val="108000"/>
-              </a:lnSpc>
-              <a:spcBef>
-                <a:spcPts val="0"/>
-              </a:spcBef>
-              <a:spcAft>
-                <a:spcPts val="0"/>
+            <a:pPr>
+              <a:lnSpc>
+                <a:spcPct val="115000"/>
+              </a:lnSpc>
+              <a:spcAft>
+                <a:spcPts val="1200"/>
               </a:spcAft>
             </a:pPr>
             <a:r>
-              <a:rPr sz="2400" b="1" lang="pl-PL">
+              <a:rPr sz="2300" b="1" lang="pl-PL">
                 <a:solidFill>
                   <a:srgbClr val="006C86"/>
                 </a:solidFill>
                 <a:latin typeface="DejaVu Sans"/>
               </a:rPr>
-              <a:t>02</a:t>
-            </a:r>
-          </a:p>
-        </p:txBody>
-      </p:sp>
-      <p:sp>
-        <p:nvSpPr>
-          <p:cNvPr id="15" name="TextBox 14"/>
+              <a:t>Odpowiedź 3</a:t>
+            </a:r>
+          </a:p>
+        </p:txBody>
+      </p:sp>
+      <p:sp>
+        <p:nvSpPr>
+          <p:cNvPr id="14" name="TextBox 13"/>
           <p:cNvSpPr txBox="1"/>
           <p:nvPr/>
         </p:nvSpPr>
         <p:spPr>
           <a:xfrm>
-            <a:off x="6291072" y="3886200"/>
-            <a:ext cx="3346704" cy="365760"/>
+            <a:off x="10369296" y="2953512"/>
+            <a:ext cx="4032504" cy="4517136"/>
           </a:xfrm>
           <a:prstGeom prst="rect">
             <a:avLst/>
@@ -10339,749 +10333,103 @@
           <a:noFill/>
         </p:spPr>
         <p:txBody>
-          <a:bodyPr wrap="square" lIns="0" rIns="0" tIns="0" bIns="0" anchor="t">
+          <a:bodyPr wrap="square" lIns="0" rIns="0" tIns="0" bIns="0">
             <a:spAutoFit/>
           </a:bodyPr>
           <a:lstStyle/>
           <a:p>
-            <a:pPr algn="l">
-              <a:lnSpc>
-                <a:spcPct val="108000"/>
-              </a:lnSpc>
-              <a:spcBef>
-                <a:spcPts val="0"/>
-              </a:spcBef>
-              <a:spcAft>
-                <a:spcPts val="0"/>
+            <a:pPr>
+              <a:lnSpc>
+                <a:spcPct val="115000"/>
+              </a:lnSpc>
+              <a:spcAft>
+                <a:spcPts val="1200"/>
               </a:spcAft>
             </a:pPr>
             <a:r>
-              <a:rPr sz="1900" b="1" lang="pl-PL">
+              <a:rPr sz="1800" b="0" lang="pl-PL">
                 <a:solidFill>
                   <a:srgbClr val="192F3C"/>
                 </a:solidFill>
                 <a:latin typeface="DejaVu Sans"/>
               </a:rPr>
-              <a:t>Najpierw doprecyzowanie</a:t>
-            </a:r>
-          </a:p>
-        </p:txBody>
-      </p:sp>
-      <p:sp>
-        <p:nvSpPr>
-          <p:cNvPr id="16" name="TextBox 15"/>
-          <p:cNvSpPr txBox="1"/>
-          <p:nvPr/>
-        </p:nvSpPr>
-        <p:spPr>
-          <a:xfrm>
-            <a:off x="5586984" y="4434840"/>
-            <a:ext cx="4041648" cy="576072"/>
-          </a:xfrm>
-          <a:prstGeom prst="rect">
-            <a:avLst/>
-          </a:prstGeom>
-          <a:noFill/>
-        </p:spPr>
-        <p:txBody>
-          <a:bodyPr wrap="square" lIns="0" rIns="0" tIns="0" bIns="0" anchor="t">
-            <a:spAutoFit/>
-          </a:bodyPr>
-          <a:lstStyle/>
+              <a:t>Dni 1–3: Bangkok — świątynie, rejs po rzece i lokalna kuchnia.</a:t>
+            </a:r>
+          </a:p>
           <a:p>
-            <a:pPr algn="l">
-              <a:lnSpc>
-                <a:spcPct val="108000"/>
-              </a:lnSpc>
-              <a:spcBef>
-                <a:spcPts val="0"/>
-              </a:spcBef>
-              <a:spcAft>
-                <a:spcPts val="0"/>
+            <a:pPr>
+              <a:lnSpc>
+                <a:spcPct val="115000"/>
+              </a:lnSpc>
+              <a:spcAft>
+                <a:spcPts val="1200"/>
               </a:spcAft>
             </a:pPr>
             <a:r>
-              <a:rPr sz="1750" b="0" lang="pl-PL">
+              <a:rPr sz="1800" b="0" lang="pl-PL">
                 <a:solidFill>
                   <a:srgbClr val="192F3C"/>
                 </a:solidFill>
                 <a:latin typeface="DejaVu Sans"/>
               </a:rPr>
-              <a:t>Pytania o zainteresowania,</a:t>
+              <a:t>Dzień 4: wycieczka do Ayutthayi i powrót do Bangkoku.</a:t>
             </a:r>
           </a:p>
           <a:p>
-            <a:pPr algn="l">
-              <a:lnSpc>
-                <a:spcPct val="108000"/>
-              </a:lnSpc>
-              <a:spcBef>
-                <a:spcPts val="0"/>
-              </a:spcBef>
-              <a:spcAft>
-                <a:spcPts val="0"/>
+            <a:pPr>
+              <a:lnSpc>
+                <a:spcPct val="115000"/>
+              </a:lnSpc>
+              <a:spcAft>
+                <a:spcPts val="1200"/>
               </a:spcAft>
             </a:pPr>
             <a:r>
-              <a:rPr sz="1750" b="0" lang="pl-PL">
+              <a:rPr sz="1800" b="0" lang="pl-PL">
                 <a:solidFill>
                   <a:srgbClr val="192F3C"/>
                 </a:solidFill>
                 <a:latin typeface="DejaVu Sans"/>
               </a:rPr>
-              <a:t>budżet i tempo podróży</a:t>
-            </a:r>
-          </a:p>
-        </p:txBody>
-      </p:sp>
-      <p:sp>
-        <p:nvSpPr>
-          <p:cNvPr id="17" name="Rectangle 16"/>
-          <p:cNvSpPr/>
-          <p:nvPr/>
-        </p:nvSpPr>
-        <p:spPr>
-          <a:xfrm>
-            <a:off x="10140696" y="3694176"/>
-            <a:ext cx="4489704" cy="1508760"/>
-          </a:xfrm>
-          <a:prstGeom prst="rect">
-            <a:avLst/>
-          </a:prstGeom>
-          <a:solidFill>
-            <a:srgbClr val="ECF4F6"/>
-          </a:solidFill>
-          <a:ln w="12700">
-            <a:solidFill>
-              <a:srgbClr val="BFD4DE"/>
-            </a:solidFill>
-          </a:ln>
-        </p:spPr>
-        <p:style>
-          <a:lnRef idx="1">
-            <a:schemeClr val="accent1"/>
-          </a:lnRef>
-          <a:fillRef idx="3">
-            <a:schemeClr val="accent1"/>
-          </a:fillRef>
-          <a:effectRef idx="2">
-            <a:schemeClr val="accent1"/>
-          </a:effectRef>
-          <a:fontRef idx="minor">
-            <a:schemeClr val="lt1"/>
-          </a:fontRef>
-        </p:style>
-        <p:txBody>
-          <a:bodyPr rtlCol="0" anchor="ctr"/>
-          <a:lstStyle/>
+              <a:t>Dni 5–8: Chiang Mai — stare miasto, Doi Suthep i jednodniowy wypad w okolice.</a:t>
+            </a:r>
+          </a:p>
           <a:p>
-            <a:pPr algn="ctr"/>
-          </a:p>
-        </p:txBody>
-      </p:sp>
-      <p:sp>
-        <p:nvSpPr>
-          <p:cNvPr id="18" name="TextBox 17"/>
-          <p:cNvSpPr txBox="1"/>
-          <p:nvPr/>
-        </p:nvSpPr>
-        <p:spPr>
-          <a:xfrm>
-            <a:off x="10341864" y="3867912"/>
-            <a:ext cx="594360" cy="365760"/>
-          </a:xfrm>
-          <a:prstGeom prst="rect">
-            <a:avLst/>
-          </a:prstGeom>
-          <a:noFill/>
-        </p:spPr>
-        <p:txBody>
-          <a:bodyPr wrap="square" lIns="0" rIns="0" tIns="0" bIns="0" anchor="t">
-            <a:spAutoFit/>
-          </a:bodyPr>
-          <a:lstStyle/>
+            <a:pPr>
+              <a:lnSpc>
+                <a:spcPct val="115000"/>
+              </a:lnSpc>
+              <a:spcAft>
+                <a:spcPts val="1200"/>
+              </a:spcAft>
+            </a:pPr>
+            <a:r>
+              <a:rPr sz="1800" b="0" lang="pl-PL">
+                <a:solidFill>
+                  <a:srgbClr val="192F3C"/>
+                </a:solidFill>
+                <a:latin typeface="DejaVu Sans"/>
+              </a:rPr>
+              <a:t>Dni 9–13: Krabi — Railay, wycieczka na wyspy i odpoczynek na plaży.</a:t>
+            </a:r>
+          </a:p>
           <a:p>
-            <a:pPr algn="l">
-              <a:lnSpc>
-                <a:spcPct val="108000"/>
-              </a:lnSpc>
-              <a:spcBef>
-                <a:spcPts val="0"/>
-              </a:spcBef>
-              <a:spcAft>
-                <a:spcPts val="0"/>
+            <a:pPr>
+              <a:lnSpc>
+                <a:spcPct val="115000"/>
+              </a:lnSpc>
+              <a:spcAft>
+                <a:spcPts val="1200"/>
               </a:spcAft>
             </a:pPr>
             <a:r>
-              <a:rPr sz="2400" b="1" lang="pl-PL">
-                <a:solidFill>
-                  <a:srgbClr val="006C86"/>
-                </a:solidFill>
-                <a:latin typeface="DejaVu Sans"/>
-              </a:rPr>
-              <a:t>03</a:t>
-            </a:r>
-          </a:p>
-        </p:txBody>
-      </p:sp>
-      <p:sp>
-        <p:nvSpPr>
-          <p:cNvPr id="19" name="TextBox 18"/>
-          <p:cNvSpPr txBox="1"/>
-          <p:nvPr/>
-        </p:nvSpPr>
-        <p:spPr>
-          <a:xfrm>
-            <a:off x="11055096" y="3886200"/>
-            <a:ext cx="3346704" cy="365760"/>
-          </a:xfrm>
-          <a:prstGeom prst="rect">
-            <a:avLst/>
-          </a:prstGeom>
-          <a:noFill/>
-        </p:spPr>
-        <p:txBody>
-          <a:bodyPr wrap="square" lIns="0" rIns="0" tIns="0" bIns="0" anchor="t">
-            <a:spAutoFit/>
-          </a:bodyPr>
-          <a:lstStyle/>
-          <a:p>
-            <a:pPr algn="l">
-              <a:lnSpc>
-                <a:spcPct val="108000"/>
-              </a:lnSpc>
-              <a:spcBef>
-                <a:spcPts val="0"/>
-              </a:spcBef>
-              <a:spcAft>
-                <a:spcPts val="0"/>
-              </a:spcAft>
-            </a:pPr>
-            <a:r>
-              <a:rPr sz="1900" b="1" lang="pl-PL">
+              <a:rPr sz="1800" b="0" lang="pl-PL">
                 <a:solidFill>
                   <a:srgbClr val="192F3C"/>
                 </a:solidFill>
                 <a:latin typeface="DejaVu Sans"/>
               </a:rPr>
-              <a:t>Plan dzień po dniu</a:t>
-            </a:r>
-          </a:p>
-        </p:txBody>
-      </p:sp>
-      <p:sp>
-        <p:nvSpPr>
-          <p:cNvPr id="20" name="TextBox 19"/>
-          <p:cNvSpPr txBox="1"/>
-          <p:nvPr/>
-        </p:nvSpPr>
-        <p:spPr>
-          <a:xfrm>
-            <a:off x="10351008" y="4434840"/>
-            <a:ext cx="4041648" cy="576072"/>
-          </a:xfrm>
-          <a:prstGeom prst="rect">
-            <a:avLst/>
-          </a:prstGeom>
-          <a:noFill/>
-        </p:spPr>
-        <p:txBody>
-          <a:bodyPr wrap="square" lIns="0" rIns="0" tIns="0" bIns="0" anchor="t">
-            <a:spAutoFit/>
-          </a:bodyPr>
-          <a:lstStyle/>
-          <a:p>
-            <a:pPr algn="l">
-              <a:lnSpc>
-                <a:spcPct val="108000"/>
-              </a:lnSpc>
-              <a:spcBef>
-                <a:spcPts val="0"/>
-              </a:spcBef>
-              <a:spcAft>
-                <a:spcPts val="0"/>
-              </a:spcAft>
-            </a:pPr>
-            <a:r>
-              <a:rPr sz="1750" b="0" lang="pl-PL">
-                <a:solidFill>
-                  <a:srgbClr val="192F3C"/>
-                </a:solidFill>
-                <a:latin typeface="DejaVu Sans"/>
-              </a:rPr>
-              <a:t>Bangkok → Chiang Mai → wyspy,</a:t>
-            </a:r>
-          </a:p>
-          <a:p>
-            <a:pPr algn="l">
-              <a:lnSpc>
-                <a:spcPct val="108000"/>
-              </a:lnSpc>
-              <a:spcBef>
-                <a:spcPts val="0"/>
-              </a:spcBef>
-              <a:spcAft>
-                <a:spcPts val="0"/>
-              </a:spcAft>
-            </a:pPr>
-            <a:r>
-              <a:rPr sz="1750" b="0" lang="pl-PL">
-                <a:solidFill>
-                  <a:srgbClr val="192F3C"/>
-                </a:solidFill>
-                <a:latin typeface="DejaVu Sans"/>
-              </a:rPr>
-              <a:t>z podziałem na dni</a:t>
-            </a:r>
-          </a:p>
-        </p:txBody>
-      </p:sp>
-      <p:sp>
-        <p:nvSpPr>
-          <p:cNvPr id="21" name="TextBox 20"/>
-          <p:cNvSpPr txBox="1"/>
-          <p:nvPr/>
-        </p:nvSpPr>
-        <p:spPr>
-          <a:xfrm>
-            <a:off x="612648" y="5431536"/>
-            <a:ext cx="13898880" cy="292608"/>
-          </a:xfrm>
-          <a:prstGeom prst="rect">
-            <a:avLst/>
-          </a:prstGeom>
-          <a:noFill/>
-        </p:spPr>
-        <p:txBody>
-          <a:bodyPr wrap="square" lIns="0" rIns="0" tIns="0" bIns="0" anchor="t">
-            <a:spAutoFit/>
-          </a:bodyPr>
-          <a:lstStyle/>
-          <a:p>
-            <a:pPr algn="l">
-              <a:lnSpc>
-                <a:spcPct val="108000"/>
-              </a:lnSpc>
-              <a:spcBef>
-                <a:spcPts val="0"/>
-              </a:spcBef>
-              <a:spcAft>
-                <a:spcPts val="0"/>
-              </a:spcAft>
-            </a:pPr>
-            <a:r>
-              <a:rPr sz="1400" b="0" lang="pl-PL">
-                <a:solidFill>
-                  <a:srgbClr val="536873"/>
-                </a:solidFill>
-                <a:latin typeface="DejaVu Sans"/>
-              </a:rPr>
-              <a:t>Przykłady poglądowe — poprawność sprawdzamy według wymagań i dowodów.</a:t>
-            </a:r>
-          </a:p>
-        </p:txBody>
-      </p:sp>
-      <p:sp>
-        <p:nvSpPr>
-          <p:cNvPr id="22" name="TextBox 21"/>
-          <p:cNvSpPr txBox="1"/>
-          <p:nvPr/>
-        </p:nvSpPr>
-        <p:spPr>
-          <a:xfrm>
-            <a:off x="612648" y="5952744"/>
-            <a:ext cx="13898880" cy="384048"/>
-          </a:xfrm>
-          <a:prstGeom prst="rect">
-            <a:avLst/>
-          </a:prstGeom>
-          <a:noFill/>
-        </p:spPr>
-        <p:txBody>
-          <a:bodyPr wrap="square" lIns="0" rIns="0" tIns="0" bIns="0" anchor="t">
-            <a:spAutoFit/>
-          </a:bodyPr>
-          <a:lstStyle/>
-          <a:p>
-            <a:pPr algn="l">
-              <a:lnSpc>
-                <a:spcPct val="108000"/>
-              </a:lnSpc>
-              <a:spcBef>
-                <a:spcPts val="0"/>
-              </a:spcBef>
-              <a:spcAft>
-                <a:spcPts val="0"/>
-              </a:spcAft>
-            </a:pPr>
-            <a:r>
-              <a:rPr sz="2300" b="1" lang="pl-PL">
-                <a:solidFill>
-                  <a:srgbClr val="006C86"/>
-                </a:solidFill>
-                <a:latin typeface="DejaVu Sans"/>
-              </a:rPr>
-              <a:t>Jak ograniczyć niepożądaną zmienność?</a:t>
-            </a:r>
-          </a:p>
-        </p:txBody>
-      </p:sp>
-      <p:sp>
-        <p:nvSpPr>
-          <p:cNvPr id="23" name="TextBox 22"/>
-          <p:cNvSpPr txBox="1"/>
-          <p:nvPr/>
-        </p:nvSpPr>
-        <p:spPr>
-          <a:xfrm>
-            <a:off x="612648" y="6574536"/>
-            <a:ext cx="3218688" cy="347472"/>
-          </a:xfrm>
-          <a:prstGeom prst="rect">
-            <a:avLst/>
-          </a:prstGeom>
-          <a:noFill/>
-        </p:spPr>
-        <p:txBody>
-          <a:bodyPr wrap="square" lIns="0" rIns="0" tIns="0" bIns="0" anchor="t">
-            <a:spAutoFit/>
-          </a:bodyPr>
-          <a:lstStyle/>
-          <a:p>
-            <a:pPr algn="l">
-              <a:lnSpc>
-                <a:spcPct val="108000"/>
-              </a:lnSpc>
-              <a:spcBef>
-                <a:spcPts val="0"/>
-              </a:spcBef>
-              <a:spcAft>
-                <a:spcPts val="0"/>
-              </a:spcAft>
-            </a:pPr>
-            <a:r>
-              <a:rPr sz="1739" b="1" lang="pl-PL">
-                <a:solidFill>
-                  <a:srgbClr val="006C86"/>
-                </a:solidFill>
-                <a:latin typeface="DejaVu Sans"/>
-              </a:rPr>
-              <a:t>Jedno zadanie na prompt</a:t>
-            </a:r>
-          </a:p>
-        </p:txBody>
-      </p:sp>
-      <p:sp>
-        <p:nvSpPr>
-          <p:cNvPr id="24" name="TextBox 23"/>
-          <p:cNvSpPr txBox="1"/>
-          <p:nvPr/>
-        </p:nvSpPr>
-        <p:spPr>
-          <a:xfrm>
-            <a:off x="612648" y="7059168"/>
-            <a:ext cx="3200400" cy="630936"/>
-          </a:xfrm>
-          <a:prstGeom prst="rect">
-            <a:avLst/>
-          </a:prstGeom>
-          <a:noFill/>
-        </p:spPr>
-        <p:txBody>
-          <a:bodyPr wrap="square" lIns="0" rIns="0" tIns="0" bIns="0" anchor="t">
-            <a:spAutoFit/>
-          </a:bodyPr>
-          <a:lstStyle/>
-          <a:p>
-            <a:pPr algn="l">
-              <a:lnSpc>
-                <a:spcPct val="108000"/>
-              </a:lnSpc>
-              <a:spcBef>
-                <a:spcPts val="0"/>
-              </a:spcBef>
-              <a:spcAft>
-                <a:spcPts val="0"/>
-              </a:spcAft>
-            </a:pPr>
-            <a:r>
-              <a:rPr sz="1620" b="0" lang="pl-PL">
-                <a:solidFill>
-                  <a:srgbClr val="192F3C"/>
-                </a:solidFill>
-                <a:latin typeface="DejaVu Sans"/>
-              </a:rPr>
-              <a:t>Dziel pracę na małe, jasno określone kroki.</a:t>
-            </a:r>
-          </a:p>
-        </p:txBody>
-      </p:sp>
-      <p:sp>
-        <p:nvSpPr>
-          <p:cNvPr id="25" name="TextBox 24"/>
-          <p:cNvSpPr txBox="1"/>
-          <p:nvPr/>
-        </p:nvSpPr>
-        <p:spPr>
-          <a:xfrm>
-            <a:off x="4187952" y="6574536"/>
-            <a:ext cx="3218688" cy="347472"/>
-          </a:xfrm>
-          <a:prstGeom prst="rect">
-            <a:avLst/>
-          </a:prstGeom>
-          <a:noFill/>
-        </p:spPr>
-        <p:txBody>
-          <a:bodyPr wrap="square" lIns="0" rIns="0" tIns="0" bIns="0" anchor="t">
-            <a:spAutoFit/>
-          </a:bodyPr>
-          <a:lstStyle/>
-          <a:p>
-            <a:pPr algn="l">
-              <a:lnSpc>
-                <a:spcPct val="108000"/>
-              </a:lnSpc>
-              <a:spcBef>
-                <a:spcPts val="0"/>
-              </a:spcBef>
-              <a:spcAft>
-                <a:spcPts val="0"/>
-              </a:spcAft>
-            </a:pPr>
-            <a:r>
-              <a:rPr sz="1739" b="1" lang="pl-PL">
-                <a:solidFill>
-                  <a:srgbClr val="006C86"/>
-                </a:solidFill>
-                <a:latin typeface="DejaVu Sans"/>
-              </a:rPr>
-              <a:t>Precyzyjne kryteria</a:t>
-            </a:r>
-          </a:p>
-        </p:txBody>
-      </p:sp>
-      <p:sp>
-        <p:nvSpPr>
-          <p:cNvPr id="26" name="TextBox 25"/>
-          <p:cNvSpPr txBox="1"/>
-          <p:nvPr/>
-        </p:nvSpPr>
-        <p:spPr>
-          <a:xfrm>
-            <a:off x="4187952" y="7059168"/>
-            <a:ext cx="3200400" cy="630936"/>
-          </a:xfrm>
-          <a:prstGeom prst="rect">
-            <a:avLst/>
-          </a:prstGeom>
-          <a:noFill/>
-        </p:spPr>
-        <p:txBody>
-          <a:bodyPr wrap="square" lIns="0" rIns="0" tIns="0" bIns="0" anchor="t">
-            <a:spAutoFit/>
-          </a:bodyPr>
-          <a:lstStyle/>
-          <a:p>
-            <a:pPr algn="l">
-              <a:lnSpc>
-                <a:spcPct val="108000"/>
-              </a:lnSpc>
-              <a:spcBef>
-                <a:spcPts val="0"/>
-              </a:spcBef>
-              <a:spcAft>
-                <a:spcPts val="0"/>
-              </a:spcAft>
-            </a:pPr>
-            <a:r>
-              <a:rPr sz="1620" b="0" lang="pl-PL">
-                <a:solidFill>
-                  <a:srgbClr val="192F3C"/>
-                </a:solidFill>
-                <a:latin typeface="DejaVu Sans"/>
-              </a:rPr>
-              <a:t>Określ źródła, format i warunki odbioru.</a:t>
-            </a:r>
-          </a:p>
-        </p:txBody>
-      </p:sp>
-      <p:sp>
-        <p:nvSpPr>
-          <p:cNvPr id="27" name="TextBox 26"/>
-          <p:cNvSpPr txBox="1"/>
-          <p:nvPr/>
-        </p:nvSpPr>
-        <p:spPr>
-          <a:xfrm>
-            <a:off x="7772400" y="6574536"/>
-            <a:ext cx="3218688" cy="347472"/>
-          </a:xfrm>
-          <a:prstGeom prst="rect">
-            <a:avLst/>
-          </a:prstGeom>
-          <a:noFill/>
-        </p:spPr>
-        <p:txBody>
-          <a:bodyPr wrap="square" lIns="0" rIns="0" tIns="0" bIns="0" anchor="t">
-            <a:spAutoFit/>
-          </a:bodyPr>
-          <a:lstStyle/>
-          <a:p>
-            <a:pPr algn="l">
-              <a:lnSpc>
-                <a:spcPct val="108000"/>
-              </a:lnSpc>
-              <a:spcBef>
-                <a:spcPts val="0"/>
-              </a:spcBef>
-              <a:spcAft>
-                <a:spcPts val="0"/>
-              </a:spcAft>
-            </a:pPr>
-            <a:r>
-              <a:rPr sz="1739" b="1" lang="pl-PL">
-                <a:solidFill>
-                  <a:srgbClr val="006C86"/>
-                </a:solidFill>
-                <a:latin typeface="DejaVu Sans"/>
-              </a:rPr>
-              <a:t>Kod do stałych reguł</a:t>
-            </a:r>
-          </a:p>
-        </p:txBody>
-      </p:sp>
-      <p:sp>
-        <p:nvSpPr>
-          <p:cNvPr id="28" name="TextBox 27"/>
-          <p:cNvSpPr txBox="1"/>
-          <p:nvPr/>
-        </p:nvSpPr>
-        <p:spPr>
-          <a:xfrm>
-            <a:off x="7772400" y="7059168"/>
-            <a:ext cx="3200400" cy="630936"/>
-          </a:xfrm>
-          <a:prstGeom prst="rect">
-            <a:avLst/>
-          </a:prstGeom>
-          <a:noFill/>
-        </p:spPr>
-        <p:txBody>
-          <a:bodyPr wrap="square" lIns="0" rIns="0" tIns="0" bIns="0" anchor="t">
-            <a:spAutoFit/>
-          </a:bodyPr>
-          <a:lstStyle/>
-          <a:p>
-            <a:pPr algn="l">
-              <a:lnSpc>
-                <a:spcPct val="108000"/>
-              </a:lnSpc>
-              <a:spcBef>
-                <a:spcPts val="0"/>
-              </a:spcBef>
-              <a:spcAft>
-                <a:spcPts val="0"/>
-              </a:spcAft>
-            </a:pPr>
-            <a:r>
-              <a:rPr sz="1620" b="0" lang="pl-PL">
-                <a:solidFill>
-                  <a:srgbClr val="192F3C"/>
-                </a:solidFill>
-                <a:latin typeface="DejaVu Sans"/>
-              </a:rPr>
-              <a:t>Obliczenia i kontrole przenieś do kodu.</a:t>
-            </a:r>
-          </a:p>
-        </p:txBody>
-      </p:sp>
-      <p:sp>
-        <p:nvSpPr>
-          <p:cNvPr id="29" name="TextBox 28"/>
-          <p:cNvSpPr txBox="1"/>
-          <p:nvPr/>
-        </p:nvSpPr>
-        <p:spPr>
-          <a:xfrm>
-            <a:off x="11356848" y="6574536"/>
-            <a:ext cx="3218688" cy="347472"/>
-          </a:xfrm>
-          <a:prstGeom prst="rect">
-            <a:avLst/>
-          </a:prstGeom>
-          <a:noFill/>
-        </p:spPr>
-        <p:txBody>
-          <a:bodyPr wrap="square" lIns="0" rIns="0" tIns="0" bIns="0" anchor="t">
-            <a:spAutoFit/>
-          </a:bodyPr>
-          <a:lstStyle/>
-          <a:p>
-            <a:pPr algn="l">
-              <a:lnSpc>
-                <a:spcPct val="108000"/>
-              </a:lnSpc>
-              <a:spcBef>
-                <a:spcPts val="0"/>
-              </a:spcBef>
-              <a:spcAft>
-                <a:spcPts val="0"/>
-              </a:spcAft>
-            </a:pPr>
-            <a:r>
-              <a:rPr sz="1739" b="1" lang="pl-PL">
-                <a:solidFill>
-                  <a:srgbClr val="006C86"/>
-                </a:solidFill>
-                <a:latin typeface="DejaVu Sans"/>
-              </a:rPr>
-              <a:t>Powtórz i porównaj</a:t>
-            </a:r>
-          </a:p>
-        </p:txBody>
-      </p:sp>
-      <p:sp>
-        <p:nvSpPr>
-          <p:cNvPr id="30" name="TextBox 29"/>
-          <p:cNvSpPr txBox="1"/>
-          <p:nvPr/>
-        </p:nvSpPr>
-        <p:spPr>
-          <a:xfrm>
-            <a:off x="11356848" y="7059168"/>
-            <a:ext cx="3200400" cy="630936"/>
-          </a:xfrm>
-          <a:prstGeom prst="rect">
-            <a:avLst/>
-          </a:prstGeom>
-          <a:noFill/>
-        </p:spPr>
-        <p:txBody>
-          <a:bodyPr wrap="square" lIns="0" rIns="0" tIns="0" bIns="0" anchor="t">
-            <a:spAutoFit/>
-          </a:bodyPr>
-          <a:lstStyle/>
-          <a:p>
-            <a:pPr algn="l">
-              <a:lnSpc>
-                <a:spcPct val="108000"/>
-              </a:lnSpc>
-              <a:spcBef>
-                <a:spcPts val="0"/>
-              </a:spcBef>
-              <a:spcAft>
-                <a:spcPts val="0"/>
-              </a:spcAft>
-            </a:pPr>
-            <a:r>
-              <a:rPr sz="1620" b="0" lang="pl-PL">
-                <a:solidFill>
-                  <a:srgbClr val="192F3C"/>
-                </a:solidFill>
-                <a:latin typeface="DejaVu Sans"/>
-              </a:rPr>
-              <a:t>Sprawdź istotne różnice w źródłach.</a:t>
+              <a:t>Dzień 14: powrót. Rozkład przejazdów i wybór wybrzeża dopasuj do terminu podróży.</a:t>
             </a:r>
           </a:p>
         </p:txBody>

</xml_diff>